<commit_message>
Canva import: 32 PPTX social templates (live text, Almarai), 1x logos
Co-Authored-By: Claude Fable 5.1 <noreply@anthropic.com>
Claude-Session: https://claude.ai/code/session_016RdNFTnCQVE9bkeLv64nYj
</commit_message>
<xml_diff>
--- a/11_Canva/Import_PPTX/Portrait/ADIG_Social_Portrait_Default_Light.pptx
+++ b/11_Canva/Import_PPTX/Portrait/ADIG_Social_Portrait_Default_Light.pptx
@@ -14,8 +14,8 @@
   <p:notesMasterIdLst>
     <p:notesMasterId r:id="rId7"/>
   </p:notesMasterIdLst>
-  <p:sldSz cx="6858000" cy="8572500"/>
-  <p:notesSz cx="8572500" cy="6858000"/>
+  <p:sldSz cx="10287000" cy="12858750"/>
+  <p:notesSz cx="12858750" cy="10287000"/>
   <p:defaultTextStyle>
     <a:lvl1pPr marL="0" algn="l" defTabSz="914400" rtl="0" eaLnBrk="1" latinLnBrk="0" hangingPunct="1">
       <a:defRPr sz="1800" kern="1200">
@@ -1233,7 +1233,7 @@
         <p:spPr>
           <a:xfrm>
             <a:off x="0" y="0"/>
-            <a:ext cx="6858000" cy="8572500"/>
+            <a:ext cx="10287000" cy="12858750"/>
           </a:xfrm>
           <a:prstGeom prst="rect">
             <a:avLst/>
@@ -1258,7 +1258,7 @@
         <p:spPr>
           <a:xfrm>
             <a:off x="0" y="0"/>
-            <a:ext cx="6858000" cy="5080000"/>
+            <a:ext cx="10287000" cy="7620000"/>
           </a:xfrm>
           <a:prstGeom prst="rect">
             <a:avLst/>
@@ -1276,7 +1276,7 @@
       </p:sp>
       <p:pic>
         <p:nvPicPr>
-          <p:cNvPr id="4" name="Image 0" descr="/home/claude/adig/pkg/Canva_Upload_Pack/01_Logo_PNG/AlDeafah-International-Group-NEG-CMYK@4x.png">    </p:cNvPr>
+          <p:cNvPr id="4" name="Image 0" descr="AlDeafah-International-Group-NEG-CMYK">    </p:cNvPr>
           <p:cNvPicPr>
             <a:picLocks noChangeAspect="1"/>
           </p:cNvPicPr>
@@ -1290,8 +1290,8 @@
         </p:blipFill>
         <p:spPr>
           <a:xfrm>
-            <a:off x="4994673" y="457200"/>
-            <a:ext cx="1406127" cy="1143000"/>
+            <a:off x="7492010" y="685800"/>
+            <a:ext cx="2109190" cy="1714500"/>
           </a:xfrm>
           <a:prstGeom prst="rect">
             <a:avLst/>
@@ -1300,7 +1300,7 @@
       </p:pic>
       <p:pic>
         <p:nvPicPr>
-          <p:cNvPr id="5" name="Image 1" descr="/home/claude/adig/pkg/Canva_Import/_assets/col10.png">    </p:cNvPr>
+          <p:cNvPr id="5" name="Image 1" descr="col10">    </p:cNvPr>
           <p:cNvPicPr>
             <a:picLocks noChangeAspect="1"/>
           </p:cNvPicPr>
@@ -1314,8 +1314,8 @@
         </p:blipFill>
         <p:spPr>
           <a:xfrm>
-            <a:off x="152400" y="152400"/>
-            <a:ext cx="897770" cy="4554409"/>
+            <a:off x="228600" y="228600"/>
+            <a:ext cx="1346655" cy="6831614"/>
           </a:xfrm>
           <a:prstGeom prst="rect">
             <a:avLst/>
@@ -1330,8 +1330,8 @@
         </p:nvSpPr>
         <p:spPr>
           <a:xfrm>
-            <a:off x="1574800" y="1905000"/>
-            <a:ext cx="4826000" cy="228600"/>
+            <a:off x="2362200" y="2857500"/>
+            <a:ext cx="7239000" cy="342900"/>
           </a:xfrm>
           <a:prstGeom prst="rect">
             <a:avLst/>
@@ -1350,7 +1350,7 @@
               <a:buNone/>
             </a:pPr>
             <a:r>
-              <a:rPr lang="ar-SA" altLang="en-US" sz="1200" b="1" spc="100" kern="0" dirty="0">
+              <a:rPr lang="ar-SA" altLang="en-US" sz="1800" b="1" spc="100" kern="0" dirty="0">
                 <a:solidFill>
                   <a:srgbClr val="D29F13"/>
                 </a:solidFill>
@@ -1360,7 +1360,7 @@
               </a:rPr>
               <a:t>إعلان  ·  ANNOUNCEMENT</a:t>
             </a:r>
-            <a:endParaRPr lang="ar-SA" sz="1200" dirty="0"/>
+            <a:endParaRPr lang="ar-SA" sz="1800" dirty="0"/>
           </a:p>
         </p:txBody>
       </p:sp>
@@ -1372,8 +1372,8 @@
         </p:nvSpPr>
         <p:spPr>
           <a:xfrm>
-            <a:off x="1574800" y="2235200"/>
-            <a:ext cx="4826000" cy="693737"/>
+            <a:off x="2362200" y="3352800"/>
+            <a:ext cx="7239000" cy="1040606"/>
           </a:xfrm>
           <a:prstGeom prst="rect">
             <a:avLst/>
@@ -1392,7 +1392,7 @@
               <a:buNone/>
             </a:pPr>
             <a:r>
-              <a:rPr lang="ar-SA" altLang="en-US" sz="3800" b="1" dirty="0">
+              <a:rPr lang="ar-SA" altLang="en-US" sz="5700" b="1" dirty="0">
                 <a:solidFill>
                   <a:srgbClr val="FFFFFF"/>
                 </a:solidFill>
@@ -1402,7 +1402,7 @@
               </a:rPr>
               <a:t>انطلاق موسم العمرة</a:t>
             </a:r>
-            <a:endParaRPr lang="ar-SA" sz="3800" dirty="0"/>
+            <a:endParaRPr lang="ar-SA" sz="5700" dirty="0"/>
           </a:p>
         </p:txBody>
       </p:sp>
@@ -1414,8 +1414,8 @@
         </p:nvSpPr>
         <p:spPr>
           <a:xfrm>
-            <a:off x="1574800" y="2879090"/>
-            <a:ext cx="4826000" cy="547688"/>
+            <a:off x="2362200" y="4318635"/>
+            <a:ext cx="7239000" cy="821531"/>
           </a:xfrm>
           <a:prstGeom prst="rect">
             <a:avLst/>
@@ -1434,7 +1434,7 @@
               <a:buNone/>
             </a:pPr>
             <a:r>
-              <a:rPr lang="ar-SA" altLang="en-US" sz="3000" dirty="0">
+              <a:rPr lang="ar-SA" altLang="en-US" sz="4500" dirty="0">
                 <a:solidFill>
                   <a:srgbClr val="FFFFFF"/>
                 </a:solidFill>
@@ -1444,7 +1444,7 @@
               </a:rPr>
               <a:t>لعام ١٤٤٨ هـ</a:t>
             </a:r>
-            <a:endParaRPr lang="ar-SA" sz="3000" dirty="0"/>
+            <a:endParaRPr lang="ar-SA" sz="4500" dirty="0"/>
           </a:p>
         </p:txBody>
       </p:sp>
@@ -1456,8 +1456,8 @@
         </p:nvSpPr>
         <p:spPr>
           <a:xfrm>
-            <a:off x="5638800" y="3495040"/>
-            <a:ext cx="762000" cy="25400"/>
+            <a:off x="8458200" y="5242560"/>
+            <a:ext cx="1143000" cy="38100"/>
           </a:xfrm>
           <a:prstGeom prst="rect">
             <a:avLst/>
@@ -1481,8 +1481,8 @@
         </p:nvSpPr>
         <p:spPr>
           <a:xfrm>
-            <a:off x="457200" y="5524500"/>
-            <a:ext cx="3886200" cy="266700"/>
+            <a:off x="685800" y="8286750"/>
+            <a:ext cx="5829300" cy="400050"/>
           </a:xfrm>
           <a:prstGeom prst="rect">
             <a:avLst/>
@@ -1501,7 +1501,7 @@
               <a:buNone/>
             </a:pPr>
             <a:r>
-              <a:rPr lang="en-US" altLang="en-US" sz="1400" dirty="0">
+              <a:rPr lang="en-US" altLang="en-US" sz="2100" dirty="0">
                 <a:solidFill>
                   <a:srgbClr val="101820">
                     <a:alpha val="75000"/>
@@ -1513,13 +1513,13 @@
               </a:rPr>
               <a:t>Umrah season 1448 — bookings now open</a:t>
             </a:r>
-            <a:endParaRPr lang="en-US" sz="1400" dirty="0"/>
+            <a:endParaRPr lang="en-US" sz="2100" dirty="0"/>
           </a:p>
         </p:txBody>
       </p:sp>
       <p:pic>
         <p:nvPicPr>
-          <p:cNvPr id="11" name="Image 2" descr="/home/claude/adig/pkg/Canva_Import/_assets/strip14.png">    </p:cNvPr>
+          <p:cNvPr id="11" name="Image 2" descr="strip14">    </p:cNvPr>
           <p:cNvPicPr>
             <a:picLocks noChangeAspect="1"/>
           </p:cNvPicPr>
@@ -1533,8 +1533,8 @@
         </p:blipFill>
         <p:spPr>
           <a:xfrm>
-            <a:off x="237635" y="7979410"/>
-            <a:ext cx="6382729" cy="440690"/>
+            <a:off x="356453" y="11969115"/>
+            <a:ext cx="9574094" cy="661035"/>
           </a:xfrm>
           <a:prstGeom prst="rect">
             <a:avLst/>
@@ -1549,8 +1549,8 @@
         </p:nvSpPr>
         <p:spPr>
           <a:xfrm>
-            <a:off x="4495800" y="5435600"/>
-            <a:ext cx="1905000" cy="406400"/>
+            <a:off x="6743700" y="8153400"/>
+            <a:ext cx="2857500" cy="609600"/>
           </a:xfrm>
           <a:prstGeom prst="rect">
             <a:avLst/>
@@ -1574,8 +1574,8 @@
         </p:nvSpPr>
         <p:spPr>
           <a:xfrm>
-            <a:off x="4495800" y="5549900"/>
-            <a:ext cx="1905000" cy="209550"/>
+            <a:off x="6743700" y="8324850"/>
+            <a:ext cx="2857500" cy="314325"/>
           </a:xfrm>
           <a:prstGeom prst="rect">
             <a:avLst/>
@@ -1594,7 +1594,7 @@
               <a:buNone/>
             </a:pPr>
             <a:r>
-              <a:rPr lang="en-US" altLang="en-US" sz="1100" b="1" dirty="0">
+              <a:rPr lang="en-US" altLang="en-US" sz="1650" b="1" dirty="0">
                 <a:solidFill>
                   <a:srgbClr val="101820"/>
                 </a:solidFill>
@@ -1604,7 +1604,7 @@
               </a:rPr>
               <a:t>www.deafah.com</a:t>
             </a:r>
-            <a:endParaRPr lang="en-US" sz="1100" dirty="0"/>
+            <a:endParaRPr lang="en-US" sz="1650" dirty="0"/>
           </a:p>
         </p:txBody>
       </p:sp>
@@ -1616,8 +1616,8 @@
         </p:nvSpPr>
         <p:spPr>
           <a:xfrm>
-            <a:off x="457200" y="6070600"/>
-            <a:ext cx="5943600" cy="6350"/>
+            <a:off x="685800" y="9105900"/>
+            <a:ext cx="8915400" cy="9525"/>
           </a:xfrm>
           <a:prstGeom prst="rect">
             <a:avLst/>
@@ -1643,8 +1643,8 @@
         </p:nvSpPr>
         <p:spPr>
           <a:xfrm>
-            <a:off x="4991100" y="6273800"/>
-            <a:ext cx="1409700" cy="406400"/>
+            <a:off x="7486650" y="9410700"/>
+            <a:ext cx="2114550" cy="609600"/>
           </a:xfrm>
           <a:prstGeom prst="rect">
             <a:avLst/>
@@ -1665,8 +1665,8 @@
         </p:nvSpPr>
         <p:spPr>
           <a:xfrm>
-            <a:off x="4991100" y="6375400"/>
-            <a:ext cx="1409700" cy="228600"/>
+            <a:off x="7486650" y="9563100"/>
+            <a:ext cx="2114550" cy="342900"/>
           </a:xfrm>
           <a:prstGeom prst="rect">
             <a:avLst/>
@@ -1685,7 +1685,7 @@
               <a:buNone/>
             </a:pPr>
             <a:r>
-              <a:rPr lang="ar-SA" altLang="en-US" sz="1200" b="1" dirty="0">
+              <a:rPr lang="ar-SA" altLang="en-US" sz="1800" b="1" dirty="0">
                 <a:solidFill>
                   <a:srgbClr val="101820"/>
                 </a:solidFill>
@@ -1695,7 +1695,7 @@
               </a:rPr>
               <a:t>عمرة</a:t>
             </a:r>
-            <a:endParaRPr lang="ar-SA" sz="1200" dirty="0"/>
+            <a:endParaRPr lang="ar-SA" sz="1800" dirty="0"/>
           </a:p>
         </p:txBody>
       </p:sp>
@@ -1707,8 +1707,8 @@
         </p:nvSpPr>
         <p:spPr>
           <a:xfrm>
-            <a:off x="3479800" y="6273800"/>
-            <a:ext cx="1409700" cy="406400"/>
+            <a:off x="5219700" y="9410700"/>
+            <a:ext cx="2114550" cy="609600"/>
           </a:xfrm>
           <a:prstGeom prst="rect">
             <a:avLst/>
@@ -1729,8 +1729,8 @@
         </p:nvSpPr>
         <p:spPr>
           <a:xfrm>
-            <a:off x="3479800" y="6375400"/>
-            <a:ext cx="1409700" cy="228600"/>
+            <a:off x="5219700" y="9563100"/>
+            <a:ext cx="2114550" cy="342900"/>
           </a:xfrm>
           <a:prstGeom prst="rect">
             <a:avLst/>
@@ -1749,7 +1749,7 @@
               <a:buNone/>
             </a:pPr>
             <a:r>
-              <a:rPr lang="ar-SA" altLang="en-US" sz="1200" b="1" dirty="0">
+              <a:rPr lang="ar-SA" altLang="en-US" sz="1800" b="1" dirty="0">
                 <a:solidFill>
                   <a:srgbClr val="101820"/>
                 </a:solidFill>
@@ -1759,7 +1759,7 @@
               </a:rPr>
               <a:t>نقل</a:t>
             </a:r>
-            <a:endParaRPr lang="ar-SA" sz="1200" dirty="0"/>
+            <a:endParaRPr lang="ar-SA" sz="1800" dirty="0"/>
           </a:p>
         </p:txBody>
       </p:sp>
@@ -1771,8 +1771,8 @@
         </p:nvSpPr>
         <p:spPr>
           <a:xfrm>
-            <a:off x="1968500" y="6273800"/>
-            <a:ext cx="1409700" cy="406400"/>
+            <a:off x="2952750" y="9410700"/>
+            <a:ext cx="2114550" cy="609600"/>
           </a:xfrm>
           <a:prstGeom prst="rect">
             <a:avLst/>
@@ -1793,8 +1793,8 @@
         </p:nvSpPr>
         <p:spPr>
           <a:xfrm>
-            <a:off x="1968500" y="6375400"/>
-            <a:ext cx="1409700" cy="228600"/>
+            <a:off x="2952750" y="9563100"/>
+            <a:ext cx="2114550" cy="342900"/>
           </a:xfrm>
           <a:prstGeom prst="rect">
             <a:avLst/>
@@ -1813,7 +1813,7 @@
               <a:buNone/>
             </a:pPr>
             <a:r>
-              <a:rPr lang="ar-SA" altLang="en-US" sz="1200" b="1" dirty="0">
+              <a:rPr lang="ar-SA" altLang="en-US" sz="1800" b="1" dirty="0">
                 <a:solidFill>
                   <a:srgbClr val="101820"/>
                 </a:solidFill>
@@ -1823,7 +1823,7 @@
               </a:rPr>
               <a:t>فنادق</a:t>
             </a:r>
-            <a:endParaRPr lang="ar-SA" sz="1200" dirty="0"/>
+            <a:endParaRPr lang="ar-SA" sz="1800" dirty="0"/>
           </a:p>
         </p:txBody>
       </p:sp>
@@ -1835,8 +1835,8 @@
         </p:nvSpPr>
         <p:spPr>
           <a:xfrm>
-            <a:off x="457200" y="6273800"/>
-            <a:ext cx="1409700" cy="406400"/>
+            <a:off x="685800" y="9410700"/>
+            <a:ext cx="2114550" cy="609600"/>
           </a:xfrm>
           <a:prstGeom prst="rect">
             <a:avLst/>
@@ -1857,8 +1857,8 @@
         </p:nvSpPr>
         <p:spPr>
           <a:xfrm>
-            <a:off x="457200" y="6375400"/>
-            <a:ext cx="1409700" cy="228600"/>
+            <a:off x="685800" y="9563100"/>
+            <a:ext cx="2114550" cy="342900"/>
           </a:xfrm>
           <a:prstGeom prst="rect">
             <a:avLst/>
@@ -1877,7 +1877,7 @@
               <a:buNone/>
             </a:pPr>
             <a:r>
-              <a:rPr lang="ar-SA" altLang="en-US" sz="1200" b="1" dirty="0">
+              <a:rPr lang="ar-SA" altLang="en-US" sz="1800" b="1" dirty="0">
                 <a:solidFill>
                   <a:srgbClr val="101820"/>
                 </a:solidFill>
@@ -1887,7 +1887,7 @@
               </a:rPr>
               <a:t>إعاشة</a:t>
             </a:r>
-            <a:endParaRPr lang="ar-SA" sz="1200" dirty="0"/>
+            <a:endParaRPr lang="ar-SA" sz="1800" dirty="0"/>
           </a:p>
         </p:txBody>
       </p:sp>
@@ -1899,8 +1899,8 @@
         </p:nvSpPr>
         <p:spPr>
           <a:xfrm>
-            <a:off x="457200" y="7661910"/>
-            <a:ext cx="5943600" cy="152400"/>
+            <a:off x="685800" y="11492865"/>
+            <a:ext cx="8915400" cy="228600"/>
           </a:xfrm>
           <a:prstGeom prst="rect">
             <a:avLst/>
@@ -1919,7 +1919,7 @@
               <a:buNone/>
             </a:pPr>
             <a:r>
-              <a:rPr lang="en-US" altLang="en-US" sz="800" spc="50" kern="0" dirty="0">
+              <a:rPr lang="en-US" altLang="en-US" sz="1200" spc="50" kern="0" dirty="0">
                 <a:solidFill>
                   <a:srgbClr val="101820">
                     <a:alpha val="60000"/>
@@ -1931,7 +1931,7 @@
               </a:rPr>
               <a:t>Al Deafah International Group  ·  Umrah  ·  Transportation  ·  Hotels  ·  Catering</a:t>
             </a:r>
-            <a:endParaRPr lang="en-US" sz="800" dirty="0"/>
+            <a:endParaRPr lang="en-US" sz="1200" dirty="0"/>
           </a:p>
         </p:txBody>
       </p:sp>
@@ -1969,7 +1969,7 @@
         <p:spPr>
           <a:xfrm>
             <a:off x="0" y="0"/>
-            <a:ext cx="6858000" cy="8572500"/>
+            <a:ext cx="10287000" cy="12858750"/>
           </a:xfrm>
           <a:prstGeom prst="rect">
             <a:avLst/>
@@ -1994,7 +1994,7 @@
         <p:spPr>
           <a:xfrm>
             <a:off x="0" y="0"/>
-            <a:ext cx="6858000" cy="5080000"/>
+            <a:ext cx="10287000" cy="7620000"/>
           </a:xfrm>
           <a:prstGeom prst="rect">
             <a:avLst/>
@@ -2012,7 +2012,7 @@
       </p:sp>
       <p:pic>
         <p:nvPicPr>
-          <p:cNvPr id="4" name="Image 0" descr="/home/claude/adig/pkg/Canva_Upload_Pack/01_Logo_PNG/AlDeafah-International-Group-NEG-CMYK@4x.png">    </p:cNvPr>
+          <p:cNvPr id="4" name="Image 0" descr="AlDeafah-International-Group-NEG-CMYK">    </p:cNvPr>
           <p:cNvPicPr>
             <a:picLocks noChangeAspect="1"/>
           </p:cNvPicPr>
@@ -2026,8 +2026,8 @@
         </p:blipFill>
         <p:spPr>
           <a:xfrm>
-            <a:off x="4994673" y="457200"/>
-            <a:ext cx="1406127" cy="1143000"/>
+            <a:off x="7492010" y="685800"/>
+            <a:ext cx="2109190" cy="1714500"/>
           </a:xfrm>
           <a:prstGeom prst="rect">
             <a:avLst/>
@@ -2036,7 +2036,7 @@
       </p:pic>
       <p:pic>
         <p:nvPicPr>
-          <p:cNvPr id="5" name="Image 1" descr="/home/claude/adig/pkg/Canva_Import/_assets/col10.png">    </p:cNvPr>
+          <p:cNvPr id="5" name="Image 1" descr="col10">    </p:cNvPr>
           <p:cNvPicPr>
             <a:picLocks noChangeAspect="1"/>
           </p:cNvPicPr>
@@ -2050,8 +2050,8 @@
         </p:blipFill>
         <p:spPr>
           <a:xfrm>
-            <a:off x="152400" y="152400"/>
-            <a:ext cx="897770" cy="4554409"/>
+            <a:off x="228600" y="228600"/>
+            <a:ext cx="1346655" cy="6831614"/>
           </a:xfrm>
           <a:prstGeom prst="rect">
             <a:avLst/>
@@ -2066,8 +2066,8 @@
         </p:nvSpPr>
         <p:spPr>
           <a:xfrm>
-            <a:off x="1574800" y="1828800"/>
-            <a:ext cx="4826000" cy="228600"/>
+            <a:off x="2362200" y="2743200"/>
+            <a:ext cx="7239000" cy="342900"/>
           </a:xfrm>
           <a:prstGeom prst="rect">
             <a:avLst/>
@@ -2086,7 +2086,7 @@
               <a:buNone/>
             </a:pPr>
             <a:r>
-              <a:rPr lang="ar-SA" altLang="en-US" sz="1200" b="1" spc="100" kern="0" dirty="0">
+              <a:rPr lang="ar-SA" altLang="en-US" sz="1800" b="1" spc="100" kern="0" dirty="0">
                 <a:solidFill>
                   <a:srgbClr val="D29F13"/>
                 </a:solidFill>
@@ -2096,7 +2096,7 @@
               </a:rPr>
               <a:t>عرض خاص  ·  SPECIAL OFFER</a:t>
             </a:r>
-            <a:endParaRPr lang="ar-SA" sz="1200" dirty="0"/>
+            <a:endParaRPr lang="ar-SA" sz="1800" dirty="0"/>
           </a:p>
         </p:txBody>
       </p:sp>
@@ -2108,8 +2108,8 @@
         </p:nvSpPr>
         <p:spPr>
           <a:xfrm>
-            <a:off x="1574800" y="2133600"/>
-            <a:ext cx="4826000" cy="1508125"/>
+            <a:off x="2362200" y="3200400"/>
+            <a:ext cx="7239000" cy="2262188"/>
           </a:xfrm>
           <a:prstGeom prst="rect">
             <a:avLst/>
@@ -2128,7 +2128,7 @@
               <a:buNone/>
             </a:pPr>
             <a:r>
-              <a:rPr lang="ar-SA" altLang="en-US" sz="9500" b="1" dirty="0">
+              <a:rPr lang="ar-SA" altLang="en-US" sz="14250" b="1" dirty="0">
                 <a:solidFill>
                   <a:srgbClr val="D29F13"/>
                 </a:solidFill>
@@ -2138,7 +2138,7 @@
               </a:rPr>
               <a:t>٢٠٪</a:t>
             </a:r>
-            <a:endParaRPr lang="ar-SA" sz="9500" dirty="0"/>
+            <a:endParaRPr lang="ar-SA" sz="14250" dirty="0"/>
           </a:p>
         </p:txBody>
       </p:sp>
@@ -2150,8 +2150,8 @@
         </p:nvSpPr>
         <p:spPr>
           <a:xfrm>
-            <a:off x="1574800" y="3390900"/>
-            <a:ext cx="4826000" cy="511175"/>
+            <a:off x="2362200" y="5086350"/>
+            <a:ext cx="7239000" cy="766762"/>
           </a:xfrm>
           <a:prstGeom prst="rect">
             <a:avLst/>
@@ -2170,7 +2170,7 @@
               <a:buNone/>
             </a:pPr>
             <a:r>
-              <a:rPr lang="ar-SA" altLang="en-US" sz="2800" b="1" dirty="0">
+              <a:rPr lang="ar-SA" altLang="en-US" sz="4200" b="1" dirty="0">
                 <a:solidFill>
                   <a:srgbClr val="FFFFFF"/>
                 </a:solidFill>
@@ -2180,7 +2180,7 @@
               </a:rPr>
               <a:t>خصم على باقات الإقامة</a:t>
             </a:r>
-            <a:endParaRPr lang="ar-SA" sz="2800" dirty="0"/>
+            <a:endParaRPr lang="ar-SA" sz="4200" dirty="0"/>
           </a:p>
         </p:txBody>
       </p:sp>
@@ -2192,8 +2192,8 @@
         </p:nvSpPr>
         <p:spPr>
           <a:xfrm>
-            <a:off x="1574800" y="3901440"/>
-            <a:ext cx="4826000" cy="209550"/>
+            <a:off x="2362200" y="5852160"/>
+            <a:ext cx="7239000" cy="314325"/>
           </a:xfrm>
           <a:prstGeom prst="rect">
             <a:avLst/>
@@ -2212,7 +2212,7 @@
               <a:buNone/>
             </a:pPr>
             <a:r>
-              <a:rPr lang="ar-SA" altLang="en-US" sz="1100" dirty="0">
+              <a:rPr lang="ar-SA" altLang="en-US" sz="1650" dirty="0">
                 <a:solidFill>
                   <a:srgbClr val="FFFFFF">
                     <a:alpha val="75000"/>
@@ -2224,7 +2224,7 @@
               </a:rPr>
               <a:t>العرض ساري حتى ٣٠ شعبان  ·  تطبّق الشروط والأحكام</a:t>
             </a:r>
-            <a:endParaRPr lang="ar-SA" sz="1100" dirty="0"/>
+            <a:endParaRPr lang="ar-SA" sz="1650" dirty="0"/>
           </a:p>
         </p:txBody>
       </p:sp>
@@ -2236,8 +2236,8 @@
         </p:nvSpPr>
         <p:spPr>
           <a:xfrm>
-            <a:off x="457200" y="5524500"/>
-            <a:ext cx="3886200" cy="266700"/>
+            <a:off x="685800" y="8286750"/>
+            <a:ext cx="5829300" cy="400050"/>
           </a:xfrm>
           <a:prstGeom prst="rect">
             <a:avLst/>
@@ -2256,7 +2256,7 @@
               <a:buNone/>
             </a:pPr>
             <a:r>
-              <a:rPr lang="en-US" altLang="en-US" sz="1400" dirty="0">
+              <a:rPr lang="en-US" altLang="en-US" sz="2100" dirty="0">
                 <a:solidFill>
                   <a:srgbClr val="101820">
                     <a:alpha val="75000"/>
@@ -2268,13 +2268,13 @@
               </a:rPr>
               <a:t>20% off accommodation packages</a:t>
             </a:r>
-            <a:endParaRPr lang="en-US" sz="1400" dirty="0"/>
+            <a:endParaRPr lang="en-US" sz="2100" dirty="0"/>
           </a:p>
         </p:txBody>
       </p:sp>
       <p:pic>
         <p:nvPicPr>
-          <p:cNvPr id="11" name="Image 2" descr="/home/claude/adig/pkg/Canva_Import/_assets/strip14.png">    </p:cNvPr>
+          <p:cNvPr id="11" name="Image 2" descr="strip14">    </p:cNvPr>
           <p:cNvPicPr>
             <a:picLocks noChangeAspect="1"/>
           </p:cNvPicPr>
@@ -2288,8 +2288,8 @@
         </p:blipFill>
         <p:spPr>
           <a:xfrm>
-            <a:off x="237635" y="7979410"/>
-            <a:ext cx="6382729" cy="440690"/>
+            <a:off x="356453" y="11969115"/>
+            <a:ext cx="9574094" cy="661035"/>
           </a:xfrm>
           <a:prstGeom prst="rect">
             <a:avLst/>
@@ -2304,8 +2304,8 @@
         </p:nvSpPr>
         <p:spPr>
           <a:xfrm>
-            <a:off x="4495800" y="5435600"/>
-            <a:ext cx="1905000" cy="406400"/>
+            <a:off x="6743700" y="8153400"/>
+            <a:ext cx="2857500" cy="609600"/>
           </a:xfrm>
           <a:prstGeom prst="rect">
             <a:avLst/>
@@ -2329,8 +2329,8 @@
         </p:nvSpPr>
         <p:spPr>
           <a:xfrm>
-            <a:off x="4495800" y="5549900"/>
-            <a:ext cx="1905000" cy="209550"/>
+            <a:off x="6743700" y="8324850"/>
+            <a:ext cx="2857500" cy="314325"/>
           </a:xfrm>
           <a:prstGeom prst="rect">
             <a:avLst/>
@@ -2349,7 +2349,7 @@
               <a:buNone/>
             </a:pPr>
             <a:r>
-              <a:rPr lang="en-US" altLang="en-US" sz="1100" b="1" dirty="0">
+              <a:rPr lang="en-US" altLang="en-US" sz="1650" b="1" dirty="0">
                 <a:solidFill>
                   <a:srgbClr val="101820"/>
                 </a:solidFill>
@@ -2359,7 +2359,7 @@
               </a:rPr>
               <a:t>www.deafah.com</a:t>
             </a:r>
-            <a:endParaRPr lang="en-US" sz="1100" dirty="0"/>
+            <a:endParaRPr lang="en-US" sz="1650" dirty="0"/>
           </a:p>
         </p:txBody>
       </p:sp>
@@ -2371,8 +2371,8 @@
         </p:nvSpPr>
         <p:spPr>
           <a:xfrm>
-            <a:off x="457200" y="6070600"/>
-            <a:ext cx="5943600" cy="6350"/>
+            <a:off x="685800" y="9105900"/>
+            <a:ext cx="8915400" cy="9525"/>
           </a:xfrm>
           <a:prstGeom prst="rect">
             <a:avLst/>
@@ -2398,8 +2398,8 @@
         </p:nvSpPr>
         <p:spPr>
           <a:xfrm>
-            <a:off x="4991100" y="6273800"/>
-            <a:ext cx="1409700" cy="406400"/>
+            <a:off x="7486650" y="9410700"/>
+            <a:ext cx="2114550" cy="609600"/>
           </a:xfrm>
           <a:prstGeom prst="rect">
             <a:avLst/>
@@ -2420,8 +2420,8 @@
         </p:nvSpPr>
         <p:spPr>
           <a:xfrm>
-            <a:off x="4991100" y="6375400"/>
-            <a:ext cx="1409700" cy="228600"/>
+            <a:off x="7486650" y="9563100"/>
+            <a:ext cx="2114550" cy="342900"/>
           </a:xfrm>
           <a:prstGeom prst="rect">
             <a:avLst/>
@@ -2440,7 +2440,7 @@
               <a:buNone/>
             </a:pPr>
             <a:r>
-              <a:rPr lang="ar-SA" altLang="en-US" sz="1200" b="1" dirty="0">
+              <a:rPr lang="ar-SA" altLang="en-US" sz="1800" b="1" dirty="0">
                 <a:solidFill>
                   <a:srgbClr val="101820"/>
                 </a:solidFill>
@@ -2450,7 +2450,7 @@
               </a:rPr>
               <a:t>عمرة</a:t>
             </a:r>
-            <a:endParaRPr lang="ar-SA" sz="1200" dirty="0"/>
+            <a:endParaRPr lang="ar-SA" sz="1800" dirty="0"/>
           </a:p>
         </p:txBody>
       </p:sp>
@@ -2462,8 +2462,8 @@
         </p:nvSpPr>
         <p:spPr>
           <a:xfrm>
-            <a:off x="3479800" y="6273800"/>
-            <a:ext cx="1409700" cy="406400"/>
+            <a:off x="5219700" y="9410700"/>
+            <a:ext cx="2114550" cy="609600"/>
           </a:xfrm>
           <a:prstGeom prst="rect">
             <a:avLst/>
@@ -2484,8 +2484,8 @@
         </p:nvSpPr>
         <p:spPr>
           <a:xfrm>
-            <a:off x="3479800" y="6375400"/>
-            <a:ext cx="1409700" cy="228600"/>
+            <a:off x="5219700" y="9563100"/>
+            <a:ext cx="2114550" cy="342900"/>
           </a:xfrm>
           <a:prstGeom prst="rect">
             <a:avLst/>
@@ -2504,7 +2504,7 @@
               <a:buNone/>
             </a:pPr>
             <a:r>
-              <a:rPr lang="ar-SA" altLang="en-US" sz="1200" b="1" dirty="0">
+              <a:rPr lang="ar-SA" altLang="en-US" sz="1800" b="1" dirty="0">
                 <a:solidFill>
                   <a:srgbClr val="101820"/>
                 </a:solidFill>
@@ -2514,7 +2514,7 @@
               </a:rPr>
               <a:t>نقل</a:t>
             </a:r>
-            <a:endParaRPr lang="ar-SA" sz="1200" dirty="0"/>
+            <a:endParaRPr lang="ar-SA" sz="1800" dirty="0"/>
           </a:p>
         </p:txBody>
       </p:sp>
@@ -2526,8 +2526,8 @@
         </p:nvSpPr>
         <p:spPr>
           <a:xfrm>
-            <a:off x="1968500" y="6273800"/>
-            <a:ext cx="1409700" cy="406400"/>
+            <a:off x="2952750" y="9410700"/>
+            <a:ext cx="2114550" cy="609600"/>
           </a:xfrm>
           <a:prstGeom prst="rect">
             <a:avLst/>
@@ -2548,8 +2548,8 @@
         </p:nvSpPr>
         <p:spPr>
           <a:xfrm>
-            <a:off x="1968500" y="6375400"/>
-            <a:ext cx="1409700" cy="228600"/>
+            <a:off x="2952750" y="9563100"/>
+            <a:ext cx="2114550" cy="342900"/>
           </a:xfrm>
           <a:prstGeom prst="rect">
             <a:avLst/>
@@ -2568,7 +2568,7 @@
               <a:buNone/>
             </a:pPr>
             <a:r>
-              <a:rPr lang="ar-SA" altLang="en-US" sz="1200" b="1" dirty="0">
+              <a:rPr lang="ar-SA" altLang="en-US" sz="1800" b="1" dirty="0">
                 <a:solidFill>
                   <a:srgbClr val="101820"/>
                 </a:solidFill>
@@ -2578,7 +2578,7 @@
               </a:rPr>
               <a:t>فنادق</a:t>
             </a:r>
-            <a:endParaRPr lang="ar-SA" sz="1200" dirty="0"/>
+            <a:endParaRPr lang="ar-SA" sz="1800" dirty="0"/>
           </a:p>
         </p:txBody>
       </p:sp>
@@ -2590,8 +2590,8 @@
         </p:nvSpPr>
         <p:spPr>
           <a:xfrm>
-            <a:off x="457200" y="6273800"/>
-            <a:ext cx="1409700" cy="406400"/>
+            <a:off x="685800" y="9410700"/>
+            <a:ext cx="2114550" cy="609600"/>
           </a:xfrm>
           <a:prstGeom prst="rect">
             <a:avLst/>
@@ -2612,8 +2612,8 @@
         </p:nvSpPr>
         <p:spPr>
           <a:xfrm>
-            <a:off x="457200" y="6375400"/>
-            <a:ext cx="1409700" cy="228600"/>
+            <a:off x="685800" y="9563100"/>
+            <a:ext cx="2114550" cy="342900"/>
           </a:xfrm>
           <a:prstGeom prst="rect">
             <a:avLst/>
@@ -2632,7 +2632,7 @@
               <a:buNone/>
             </a:pPr>
             <a:r>
-              <a:rPr lang="ar-SA" altLang="en-US" sz="1200" b="1" dirty="0">
+              <a:rPr lang="ar-SA" altLang="en-US" sz="1800" b="1" dirty="0">
                 <a:solidFill>
                   <a:srgbClr val="101820"/>
                 </a:solidFill>
@@ -2642,7 +2642,7 @@
               </a:rPr>
               <a:t>إعاشة</a:t>
             </a:r>
-            <a:endParaRPr lang="ar-SA" sz="1200" dirty="0"/>
+            <a:endParaRPr lang="ar-SA" sz="1800" dirty="0"/>
           </a:p>
         </p:txBody>
       </p:sp>
@@ -2654,8 +2654,8 @@
         </p:nvSpPr>
         <p:spPr>
           <a:xfrm>
-            <a:off x="457200" y="7661910"/>
-            <a:ext cx="5943600" cy="152400"/>
+            <a:off x="685800" y="11492865"/>
+            <a:ext cx="8915400" cy="228600"/>
           </a:xfrm>
           <a:prstGeom prst="rect">
             <a:avLst/>
@@ -2674,7 +2674,7 @@
               <a:buNone/>
             </a:pPr>
             <a:r>
-              <a:rPr lang="en-US" altLang="en-US" sz="800" spc="50" kern="0" dirty="0">
+              <a:rPr lang="en-US" altLang="en-US" sz="1200" spc="50" kern="0" dirty="0">
                 <a:solidFill>
                   <a:srgbClr val="101820">
                     <a:alpha val="60000"/>
@@ -2686,7 +2686,7 @@
               </a:rPr>
               <a:t>Al Deafah International Group  ·  Umrah  ·  Transportation  ·  Hotels  ·  Catering</a:t>
             </a:r>
-            <a:endParaRPr lang="en-US" sz="800" dirty="0"/>
+            <a:endParaRPr lang="en-US" sz="1200" dirty="0"/>
           </a:p>
         </p:txBody>
       </p:sp>
@@ -2724,7 +2724,7 @@
         <p:spPr>
           <a:xfrm>
             <a:off x="0" y="0"/>
-            <a:ext cx="6858000" cy="8572500"/>
+            <a:ext cx="10287000" cy="12858750"/>
           </a:xfrm>
           <a:prstGeom prst="rect">
             <a:avLst/>
@@ -2742,7 +2742,7 @@
       </p:sp>
       <p:pic>
         <p:nvPicPr>
-          <p:cNvPr id="3" name="Image 0" descr="/home/claude/adig/pkg/Canva_Import/_assets/photo_placeholder.png">    </p:cNvPr>
+          <p:cNvPr id="3" name="Image 0" descr="photo_placeholder">    </p:cNvPr>
           <p:cNvPicPr>
             <a:picLocks noChangeAspect="1"/>
           </p:cNvPicPr>
@@ -2757,7 +2757,7 @@
         <p:spPr>
           <a:xfrm>
             <a:off x="0" y="0"/>
-            <a:ext cx="6858000" cy="5080000"/>
+            <a:ext cx="10287000" cy="7620000"/>
           </a:xfrm>
           <a:prstGeom prst="rect">
             <a:avLst/>
@@ -2766,7 +2766,7 @@
       </p:pic>
       <p:pic>
         <p:nvPicPr>
-          <p:cNvPr id="4" name="Image 1" descr="/home/claude/adig/pkg/Canva_Import/_assets/grad_black.png">    </p:cNvPr>
+          <p:cNvPr id="4" name="Image 1" descr="grad_black">    </p:cNvPr>
           <p:cNvPicPr>
             <a:picLocks noChangeAspect="1"/>
           </p:cNvPicPr>
@@ -2780,8 +2780,8 @@
         </p:blipFill>
         <p:spPr>
           <a:xfrm>
-            <a:off x="0" y="1778000"/>
-            <a:ext cx="6858000" cy="3302000"/>
+            <a:off x="0" y="2667000"/>
+            <a:ext cx="10287000" cy="4953000"/>
           </a:xfrm>
           <a:prstGeom prst="rect">
             <a:avLst/>
@@ -2790,7 +2790,7 @@
       </p:pic>
       <p:pic>
         <p:nvPicPr>
-          <p:cNvPr id="5" name="Image 2" descr="/home/claude/adig/pkg/Canva_Upload_Pack/01_Logo_PNG/AlDeafah-International-Group-NEG-CMYK@4x.png">    </p:cNvPr>
+          <p:cNvPr id="5" name="Image 2" descr="AlDeafah-International-Group-NEG-CMYK">    </p:cNvPr>
           <p:cNvPicPr>
             <a:picLocks noChangeAspect="1"/>
           </p:cNvPicPr>
@@ -2804,8 +2804,8 @@
         </p:blipFill>
         <p:spPr>
           <a:xfrm>
-            <a:off x="4994673" y="457200"/>
-            <a:ext cx="1406127" cy="1143000"/>
+            <a:off x="7492010" y="685800"/>
+            <a:ext cx="2109190" cy="1714500"/>
           </a:xfrm>
           <a:prstGeom prst="rect">
             <a:avLst/>
@@ -2820,8 +2820,8 @@
         </p:nvSpPr>
         <p:spPr>
           <a:xfrm>
-            <a:off x="457200" y="3096260"/>
-            <a:ext cx="5943600" cy="228600"/>
+            <a:off x="685800" y="4644390"/>
+            <a:ext cx="8915400" cy="342900"/>
           </a:xfrm>
           <a:prstGeom prst="rect">
             <a:avLst/>
@@ -2840,7 +2840,7 @@
               <a:buNone/>
             </a:pPr>
             <a:r>
-              <a:rPr lang="ar-SA" altLang="en-US" sz="1200" b="1" spc="100" kern="0" dirty="0">
+              <a:rPr lang="ar-SA" altLang="en-US" sz="1800" b="1" spc="100" kern="0" dirty="0">
                 <a:solidFill>
                   <a:srgbClr val="D29F13"/>
                 </a:solidFill>
@@ -2850,7 +2850,7 @@
               </a:rPr>
               <a:t>عقاراتنا  ·  OUR PROPERTIES</a:t>
             </a:r>
-            <a:endParaRPr lang="ar-SA" sz="1200" dirty="0"/>
+            <a:endParaRPr lang="ar-SA" sz="1800" dirty="0"/>
           </a:p>
         </p:txBody>
       </p:sp>
@@ -2862,8 +2862,8 @@
         </p:nvSpPr>
         <p:spPr>
           <a:xfrm>
-            <a:off x="457200" y="3375660"/>
-            <a:ext cx="5943600" cy="693737"/>
+            <a:off x="685800" y="5063490"/>
+            <a:ext cx="8915400" cy="1040606"/>
           </a:xfrm>
           <a:prstGeom prst="rect">
             <a:avLst/>
@@ -2882,7 +2882,7 @@
               <a:buNone/>
             </a:pPr>
             <a:r>
-              <a:rPr lang="ar-SA" altLang="en-US" sz="3800" b="1" dirty="0">
+              <a:rPr lang="ar-SA" altLang="en-US" sz="5700" b="1" dirty="0">
                 <a:solidFill>
                   <a:srgbClr val="FFFFFF"/>
                 </a:solidFill>
@@ -2892,7 +2892,7 @@
               </a:rPr>
               <a:t>إطلالة على الحرم</a:t>
             </a:r>
-            <a:endParaRPr lang="ar-SA" sz="3800" dirty="0"/>
+            <a:endParaRPr lang="ar-SA" sz="5700" dirty="0"/>
           </a:p>
         </p:txBody>
       </p:sp>
@@ -2904,8 +2904,8 @@
         </p:nvSpPr>
         <p:spPr>
           <a:xfrm>
-            <a:off x="457200" y="4032250"/>
-            <a:ext cx="5943600" cy="547688"/>
+            <a:off x="685800" y="6048375"/>
+            <a:ext cx="8915400" cy="821531"/>
           </a:xfrm>
           <a:prstGeom prst="rect">
             <a:avLst/>
@@ -2924,7 +2924,7 @@
               <a:buNone/>
             </a:pPr>
             <a:r>
-              <a:rPr lang="ar-SA" altLang="en-US" sz="3000" dirty="0">
+              <a:rPr lang="ar-SA" altLang="en-US" sz="4500" dirty="0">
                 <a:solidFill>
                   <a:srgbClr val="FFFFFF"/>
                 </a:solidFill>
@@ -2934,7 +2934,7 @@
               </a:rPr>
               <a:t>أجنحة في قلب مكة المكرمة</a:t>
             </a:r>
-            <a:endParaRPr lang="ar-SA" sz="3000" dirty="0"/>
+            <a:endParaRPr lang="ar-SA" sz="4500" dirty="0"/>
           </a:p>
         </p:txBody>
       </p:sp>
@@ -2946,8 +2946,8 @@
         </p:nvSpPr>
         <p:spPr>
           <a:xfrm>
-            <a:off x="457200" y="5524500"/>
-            <a:ext cx="3886200" cy="266700"/>
+            <a:off x="685800" y="8286750"/>
+            <a:ext cx="5829300" cy="400050"/>
           </a:xfrm>
           <a:prstGeom prst="rect">
             <a:avLst/>
@@ -2966,7 +2966,7 @@
               <a:buNone/>
             </a:pPr>
             <a:r>
-              <a:rPr lang="en-US" altLang="en-US" sz="1400" dirty="0">
+              <a:rPr lang="en-US" altLang="en-US" sz="2100" dirty="0">
                 <a:solidFill>
                   <a:srgbClr val="101820">
                     <a:alpha val="75000"/>
@@ -2978,13 +2978,13 @@
               </a:rPr>
               <a:t>Suites in the heart of Makkah</a:t>
             </a:r>
-            <a:endParaRPr lang="en-US" sz="1400" dirty="0"/>
+            <a:endParaRPr lang="en-US" sz="2100" dirty="0"/>
           </a:p>
         </p:txBody>
       </p:sp>
       <p:pic>
         <p:nvPicPr>
-          <p:cNvPr id="10" name="Image 3" descr="/home/claude/adig/pkg/Canva_Import/_assets/strip14.png">    </p:cNvPr>
+          <p:cNvPr id="10" name="Image 3" descr="strip14">    </p:cNvPr>
           <p:cNvPicPr>
             <a:picLocks noChangeAspect="1"/>
           </p:cNvPicPr>
@@ -2998,8 +2998,8 @@
         </p:blipFill>
         <p:spPr>
           <a:xfrm>
-            <a:off x="237635" y="7979410"/>
-            <a:ext cx="6382729" cy="440690"/>
+            <a:off x="356453" y="11969115"/>
+            <a:ext cx="9574094" cy="661035"/>
           </a:xfrm>
           <a:prstGeom prst="rect">
             <a:avLst/>
@@ -3014,8 +3014,8 @@
         </p:nvSpPr>
         <p:spPr>
           <a:xfrm>
-            <a:off x="4495800" y="5435600"/>
-            <a:ext cx="1905000" cy="406400"/>
+            <a:off x="6743700" y="8153400"/>
+            <a:ext cx="2857500" cy="609600"/>
           </a:xfrm>
           <a:prstGeom prst="rect">
             <a:avLst/>
@@ -3039,8 +3039,8 @@
         </p:nvSpPr>
         <p:spPr>
           <a:xfrm>
-            <a:off x="4495800" y="5549900"/>
-            <a:ext cx="1905000" cy="209550"/>
+            <a:off x="6743700" y="8324850"/>
+            <a:ext cx="2857500" cy="314325"/>
           </a:xfrm>
           <a:prstGeom prst="rect">
             <a:avLst/>
@@ -3059,7 +3059,7 @@
               <a:buNone/>
             </a:pPr>
             <a:r>
-              <a:rPr lang="en-US" altLang="en-US" sz="1100" b="1" dirty="0">
+              <a:rPr lang="en-US" altLang="en-US" sz="1650" b="1" dirty="0">
                 <a:solidFill>
                   <a:srgbClr val="101820"/>
                 </a:solidFill>
@@ -3069,7 +3069,7 @@
               </a:rPr>
               <a:t>www.deafah.com</a:t>
             </a:r>
-            <a:endParaRPr lang="en-US" sz="1100" dirty="0"/>
+            <a:endParaRPr lang="en-US" sz="1650" dirty="0"/>
           </a:p>
         </p:txBody>
       </p:sp>
@@ -3081,8 +3081,8 @@
         </p:nvSpPr>
         <p:spPr>
           <a:xfrm>
-            <a:off x="457200" y="6070600"/>
-            <a:ext cx="5943600" cy="6350"/>
+            <a:off x="685800" y="9105900"/>
+            <a:ext cx="8915400" cy="9525"/>
           </a:xfrm>
           <a:prstGeom prst="rect">
             <a:avLst/>
@@ -3108,8 +3108,8 @@
         </p:nvSpPr>
         <p:spPr>
           <a:xfrm>
-            <a:off x="4991100" y="6273800"/>
-            <a:ext cx="1409700" cy="406400"/>
+            <a:off x="7486650" y="9410700"/>
+            <a:ext cx="2114550" cy="609600"/>
           </a:xfrm>
           <a:prstGeom prst="rect">
             <a:avLst/>
@@ -3130,8 +3130,8 @@
         </p:nvSpPr>
         <p:spPr>
           <a:xfrm>
-            <a:off x="4991100" y="6375400"/>
-            <a:ext cx="1409700" cy="228600"/>
+            <a:off x="7486650" y="9563100"/>
+            <a:ext cx="2114550" cy="342900"/>
           </a:xfrm>
           <a:prstGeom prst="rect">
             <a:avLst/>
@@ -3150,7 +3150,7 @@
               <a:buNone/>
             </a:pPr>
             <a:r>
-              <a:rPr lang="ar-SA" altLang="en-US" sz="1200" b="1" dirty="0">
+              <a:rPr lang="ar-SA" altLang="en-US" sz="1800" b="1" dirty="0">
                 <a:solidFill>
                   <a:srgbClr val="101820"/>
                 </a:solidFill>
@@ -3160,7 +3160,7 @@
               </a:rPr>
               <a:t>عمرة</a:t>
             </a:r>
-            <a:endParaRPr lang="ar-SA" sz="1200" dirty="0"/>
+            <a:endParaRPr lang="ar-SA" sz="1800" dirty="0"/>
           </a:p>
         </p:txBody>
       </p:sp>
@@ -3172,8 +3172,8 @@
         </p:nvSpPr>
         <p:spPr>
           <a:xfrm>
-            <a:off x="3479800" y="6273800"/>
-            <a:ext cx="1409700" cy="406400"/>
+            <a:off x="5219700" y="9410700"/>
+            <a:ext cx="2114550" cy="609600"/>
           </a:xfrm>
           <a:prstGeom prst="rect">
             <a:avLst/>
@@ -3194,8 +3194,8 @@
         </p:nvSpPr>
         <p:spPr>
           <a:xfrm>
-            <a:off x="3479800" y="6375400"/>
-            <a:ext cx="1409700" cy="228600"/>
+            <a:off x="5219700" y="9563100"/>
+            <a:ext cx="2114550" cy="342900"/>
           </a:xfrm>
           <a:prstGeom prst="rect">
             <a:avLst/>
@@ -3214,7 +3214,7 @@
               <a:buNone/>
             </a:pPr>
             <a:r>
-              <a:rPr lang="ar-SA" altLang="en-US" sz="1200" b="1" dirty="0">
+              <a:rPr lang="ar-SA" altLang="en-US" sz="1800" b="1" dirty="0">
                 <a:solidFill>
                   <a:srgbClr val="101820"/>
                 </a:solidFill>
@@ -3224,7 +3224,7 @@
               </a:rPr>
               <a:t>نقل</a:t>
             </a:r>
-            <a:endParaRPr lang="ar-SA" sz="1200" dirty="0"/>
+            <a:endParaRPr lang="ar-SA" sz="1800" dirty="0"/>
           </a:p>
         </p:txBody>
       </p:sp>
@@ -3236,8 +3236,8 @@
         </p:nvSpPr>
         <p:spPr>
           <a:xfrm>
-            <a:off x="1968500" y="6273800"/>
-            <a:ext cx="1409700" cy="406400"/>
+            <a:off x="2952750" y="9410700"/>
+            <a:ext cx="2114550" cy="609600"/>
           </a:xfrm>
           <a:prstGeom prst="rect">
             <a:avLst/>
@@ -3258,8 +3258,8 @@
         </p:nvSpPr>
         <p:spPr>
           <a:xfrm>
-            <a:off x="1968500" y="6375400"/>
-            <a:ext cx="1409700" cy="228600"/>
+            <a:off x="2952750" y="9563100"/>
+            <a:ext cx="2114550" cy="342900"/>
           </a:xfrm>
           <a:prstGeom prst="rect">
             <a:avLst/>
@@ -3278,7 +3278,7 @@
               <a:buNone/>
             </a:pPr>
             <a:r>
-              <a:rPr lang="ar-SA" altLang="en-US" sz="1200" b="1" dirty="0">
+              <a:rPr lang="ar-SA" altLang="en-US" sz="1800" b="1" dirty="0">
                 <a:solidFill>
                   <a:srgbClr val="101820"/>
                 </a:solidFill>
@@ -3288,7 +3288,7 @@
               </a:rPr>
               <a:t>فنادق</a:t>
             </a:r>
-            <a:endParaRPr lang="ar-SA" sz="1200" dirty="0"/>
+            <a:endParaRPr lang="ar-SA" sz="1800" dirty="0"/>
           </a:p>
         </p:txBody>
       </p:sp>
@@ -3300,8 +3300,8 @@
         </p:nvSpPr>
         <p:spPr>
           <a:xfrm>
-            <a:off x="457200" y="6273800"/>
-            <a:ext cx="1409700" cy="406400"/>
+            <a:off x="685800" y="9410700"/>
+            <a:ext cx="2114550" cy="609600"/>
           </a:xfrm>
           <a:prstGeom prst="rect">
             <a:avLst/>
@@ -3322,8 +3322,8 @@
         </p:nvSpPr>
         <p:spPr>
           <a:xfrm>
-            <a:off x="457200" y="6375400"/>
-            <a:ext cx="1409700" cy="228600"/>
+            <a:off x="685800" y="9563100"/>
+            <a:ext cx="2114550" cy="342900"/>
           </a:xfrm>
           <a:prstGeom prst="rect">
             <a:avLst/>
@@ -3342,7 +3342,7 @@
               <a:buNone/>
             </a:pPr>
             <a:r>
-              <a:rPr lang="ar-SA" altLang="en-US" sz="1200" b="1" dirty="0">
+              <a:rPr lang="ar-SA" altLang="en-US" sz="1800" b="1" dirty="0">
                 <a:solidFill>
                   <a:srgbClr val="101820"/>
                 </a:solidFill>
@@ -3352,7 +3352,7 @@
               </a:rPr>
               <a:t>إعاشة</a:t>
             </a:r>
-            <a:endParaRPr lang="ar-SA" sz="1200" dirty="0"/>
+            <a:endParaRPr lang="ar-SA" sz="1800" dirty="0"/>
           </a:p>
         </p:txBody>
       </p:sp>
@@ -3364,8 +3364,8 @@
         </p:nvSpPr>
         <p:spPr>
           <a:xfrm>
-            <a:off x="457200" y="7661910"/>
-            <a:ext cx="5943600" cy="152400"/>
+            <a:off x="685800" y="11492865"/>
+            <a:ext cx="8915400" cy="228600"/>
           </a:xfrm>
           <a:prstGeom prst="rect">
             <a:avLst/>
@@ -3384,7 +3384,7 @@
               <a:buNone/>
             </a:pPr>
             <a:r>
-              <a:rPr lang="en-US" altLang="en-US" sz="800" spc="50" kern="0" dirty="0">
+              <a:rPr lang="en-US" altLang="en-US" sz="1200" spc="50" kern="0" dirty="0">
                 <a:solidFill>
                   <a:srgbClr val="101820">
                     <a:alpha val="60000"/>
@@ -3396,7 +3396,7 @@
               </a:rPr>
               <a:t>Al Deafah International Group  ·  Umrah  ·  Transportation  ·  Hotels  ·  Catering</a:t>
             </a:r>
-            <a:endParaRPr lang="en-US" sz="800" dirty="0"/>
+            <a:endParaRPr lang="en-US" sz="1200" dirty="0"/>
           </a:p>
         </p:txBody>
       </p:sp>
@@ -3434,7 +3434,7 @@
         <p:spPr>
           <a:xfrm>
             <a:off x="0" y="0"/>
-            <a:ext cx="6858000" cy="8572500"/>
+            <a:ext cx="10287000" cy="12858750"/>
           </a:xfrm>
           <a:prstGeom prst="rect">
             <a:avLst/>
@@ -3452,7 +3452,7 @@
       </p:sp>
       <p:pic>
         <p:nvPicPr>
-          <p:cNvPr id="3" name="Image 0" descr="/home/claude/adig/pkg/Canva_Upload_Pack/01_Logo_PNG/AlDeafah-International-Group-NEG-CMYK@4x.png">    </p:cNvPr>
+          <p:cNvPr id="3" name="Image 0" descr="AlDeafah-International-Group-NEG-CMYK">    </p:cNvPr>
           <p:cNvPicPr>
             <a:picLocks noChangeAspect="1"/>
           </p:cNvPicPr>
@@ -3466,8 +3466,8 @@
         </p:blipFill>
         <p:spPr>
           <a:xfrm>
-            <a:off x="2647819" y="457200"/>
-            <a:ext cx="1562363" cy="1270000"/>
+            <a:off x="3971728" y="685800"/>
+            <a:ext cx="2343544" cy="1905000"/>
           </a:xfrm>
           <a:prstGeom prst="rect">
             <a:avLst/>
@@ -3476,7 +3476,7 @@
       </p:pic>
       <p:pic>
         <p:nvPicPr>
-          <p:cNvPr id="4" name="Image 1" descr="/home/claude/adig/pkg/Canva_Import/_assets/field5x2.png">    </p:cNvPr>
+          <p:cNvPr id="4" name="Image 1" descr="field5x2">    </p:cNvPr>
           <p:cNvPicPr>
             <a:picLocks noChangeAspect="1"/>
           </p:cNvPicPr>
@@ -3490,8 +3490,8 @@
         </p:blipFill>
         <p:spPr>
           <a:xfrm>
-            <a:off x="2294495" y="2032000"/>
-            <a:ext cx="2269010" cy="897770"/>
+            <a:off x="3441743" y="3048000"/>
+            <a:ext cx="3403515" cy="1346655"/>
           </a:xfrm>
           <a:prstGeom prst="rect">
             <a:avLst/>
@@ -3506,8 +3506,8 @@
         </p:nvSpPr>
         <p:spPr>
           <a:xfrm>
-            <a:off x="457200" y="3285370"/>
-            <a:ext cx="5943600" cy="876300"/>
+            <a:off x="685800" y="4928055"/>
+            <a:ext cx="8915400" cy="1314450"/>
           </a:xfrm>
           <a:prstGeom prst="rect">
             <a:avLst/>
@@ -3526,7 +3526,7 @@
               <a:buNone/>
             </a:pPr>
             <a:r>
-              <a:rPr lang="ar-SA" altLang="en-US" sz="4800" b="1" dirty="0">
+              <a:rPr lang="ar-SA" altLang="en-US" sz="7200" b="1" dirty="0">
                 <a:solidFill>
                   <a:srgbClr val="D29F13"/>
                 </a:solidFill>
@@ -3536,7 +3536,7 @@
               </a:rPr>
               <a:t>رمضان مبارك</a:t>
             </a:r>
-            <a:endParaRPr lang="ar-SA" sz="4800" dirty="0"/>
+            <a:endParaRPr lang="ar-SA" sz="7200" dirty="0"/>
           </a:p>
         </p:txBody>
       </p:sp>
@@ -3548,8 +3548,8 @@
         </p:nvSpPr>
         <p:spPr>
           <a:xfrm>
-            <a:off x="457200" y="4113410"/>
-            <a:ext cx="5943600" cy="285750"/>
+            <a:off x="685800" y="6170115"/>
+            <a:ext cx="8915400" cy="428625"/>
           </a:xfrm>
           <a:prstGeom prst="rect">
             <a:avLst/>
@@ -3568,7 +3568,7 @@
               <a:buNone/>
             </a:pPr>
             <a:r>
-              <a:rPr lang="en-US" altLang="en-US" sz="1500" spc="300" kern="0" dirty="0">
+              <a:rPr lang="en-US" altLang="en-US" sz="2250" spc="300" kern="0" dirty="0">
                 <a:solidFill>
                   <a:srgbClr val="FFFFFF"/>
                 </a:solidFill>
@@ -3578,7 +3578,7 @@
               </a:rPr>
               <a:t>Ramadan Mubarak</a:t>
             </a:r>
-            <a:endParaRPr lang="en-US" sz="1500" dirty="0"/>
+            <a:endParaRPr lang="en-US" sz="2250" dirty="0"/>
           </a:p>
         </p:txBody>
       </p:sp>
@@ -3590,8 +3590,8 @@
         </p:nvSpPr>
         <p:spPr>
           <a:xfrm>
-            <a:off x="457200" y="4529335"/>
-            <a:ext cx="5943600" cy="247650"/>
+            <a:off x="685800" y="6794002"/>
+            <a:ext cx="8915400" cy="371475"/>
           </a:xfrm>
           <a:prstGeom prst="rect">
             <a:avLst/>
@@ -3610,7 +3610,7 @@
               <a:buNone/>
             </a:pPr>
             <a:r>
-              <a:rPr lang="ar-SA" altLang="en-US" sz="1300" dirty="0">
+              <a:rPr lang="ar-SA" altLang="en-US" sz="1950" dirty="0">
                 <a:solidFill>
                   <a:srgbClr val="FFFFFF">
                     <a:alpha val="80000"/>
@@ -3622,13 +3622,13 @@
               </a:rPr>
               <a:t>تتمنّى لكم مجموعة الضيافة العالمية شهراً مباركاً</a:t>
             </a:r>
-            <a:endParaRPr lang="ar-SA" sz="1300" dirty="0"/>
+            <a:endParaRPr lang="ar-SA" sz="1950" dirty="0"/>
           </a:p>
         </p:txBody>
       </p:sp>
       <p:pic>
         <p:nvPicPr>
-          <p:cNvPr id="8" name="Image 2" descr="/home/claude/adig/pkg/Canva_Import/_assets/strip14.png">    </p:cNvPr>
+          <p:cNvPr id="8" name="Image 2" descr="strip14">    </p:cNvPr>
           <p:cNvPicPr>
             <a:picLocks noChangeAspect="1"/>
           </p:cNvPicPr>
@@ -3642,8 +3642,8 @@
         </p:blipFill>
         <p:spPr>
           <a:xfrm>
-            <a:off x="237635" y="7979410"/>
-            <a:ext cx="6382729" cy="440690"/>
+            <a:off x="356453" y="11969115"/>
+            <a:ext cx="9574094" cy="661035"/>
           </a:xfrm>
           <a:prstGeom prst="rect">
             <a:avLst/>
@@ -3684,7 +3684,7 @@
         <p:spPr>
           <a:xfrm>
             <a:off x="0" y="0"/>
-            <a:ext cx="6858000" cy="8572500"/>
+            <a:ext cx="10287000" cy="12858750"/>
           </a:xfrm>
           <a:prstGeom prst="rect">
             <a:avLst/>
@@ -3708,8 +3708,8 @@
         </p:nvSpPr>
         <p:spPr>
           <a:xfrm>
-            <a:off x="457200" y="457200"/>
-            <a:ext cx="5943600" cy="323850"/>
+            <a:off x="685800" y="685800"/>
+            <a:ext cx="8915400" cy="485775"/>
           </a:xfrm>
           <a:prstGeom prst="rect">
             <a:avLst/>
@@ -3728,7 +3728,7 @@
               <a:buNone/>
             </a:pPr>
             <a:r>
-              <a:rPr lang="ar-SA" altLang="en-US" sz="1700" b="1" dirty="0">
+              <a:rPr lang="ar-SA" altLang="en-US" sz="2550" b="1" dirty="0">
                 <a:solidFill>
                   <a:srgbClr val="101820"/>
                 </a:solidFill>
@@ -3738,7 +3738,7 @@
               </a:rPr>
               <a:t>قائمة ما قبل النشر — احذف هذه الصفحة قبل التصدير</a:t>
             </a:r>
-            <a:endParaRPr lang="ar-SA" sz="1700" dirty="0"/>
+            <a:endParaRPr lang="ar-SA" sz="2550" dirty="0"/>
           </a:p>
         </p:txBody>
       </p:sp>
@@ -3750,8 +3750,8 @@
         </p:nvSpPr>
         <p:spPr>
           <a:xfrm>
-            <a:off x="5638800" y="901700"/>
-            <a:ext cx="762000" cy="25400"/>
+            <a:off x="8458200" y="1352550"/>
+            <a:ext cx="1143000" cy="38100"/>
           </a:xfrm>
           <a:prstGeom prst="rect">
             <a:avLst/>
@@ -3775,8 +3775,8 @@
         </p:nvSpPr>
         <p:spPr>
           <a:xfrm>
-            <a:off x="457200" y="1130300"/>
-            <a:ext cx="5943600" cy="244475"/>
+            <a:off x="685800" y="1695450"/>
+            <a:ext cx="8915400" cy="366713"/>
           </a:xfrm>
           <a:prstGeom prst="rect">
             <a:avLst/>
@@ -3795,7 +3795,7 @@
               <a:buNone/>
             </a:pPr>
             <a:r>
-              <a:rPr lang="ar-SA" altLang="en-US" sz="1100" dirty="0">
+              <a:rPr lang="ar-SA" altLang="en-US" sz="1650" dirty="0">
                 <a:solidFill>
                   <a:srgbClr val="101820"/>
                 </a:solidFill>
@@ -3805,7 +3805,7 @@
               </a:rPr>
               <a:t>☐  الشعار من Brand Kit أو المجلد 01 فقط؛ بلا تمدد أو تدوير أو ظل أو تغيير لون.</a:t>
             </a:r>
-            <a:endParaRPr lang="ar-SA" sz="1100" dirty="0"/>
+            <a:endParaRPr lang="ar-SA" sz="1650" dirty="0"/>
           </a:p>
         </p:txBody>
       </p:sp>
@@ -3817,8 +3817,8 @@
         </p:nvSpPr>
         <p:spPr>
           <a:xfrm>
-            <a:off x="457200" y="1395730"/>
-            <a:ext cx="5943600" cy="244475"/>
+            <a:off x="685800" y="2093595"/>
+            <a:ext cx="8915400" cy="366713"/>
           </a:xfrm>
           <a:prstGeom prst="rect">
             <a:avLst/>
@@ -3837,7 +3837,7 @@
               <a:buNone/>
             </a:pPr>
             <a:r>
-              <a:rPr lang="ar-SA" altLang="en-US" sz="1100" dirty="0">
+              <a:rPr lang="ar-SA" altLang="en-US" sz="1650" dirty="0">
                 <a:solidFill>
                   <a:srgbClr val="101820"/>
                 </a:solidFill>
@@ -3847,7 +3847,7 @@
               </a:rPr>
               <a:t>☐  مسافة آمنة حول الشعار ≥ 0.42 × ارتفاع الرمز، وبعيد عن الحواف بالقدر نفسه.</a:t>
             </a:r>
-            <a:endParaRPr lang="ar-SA" sz="1100" dirty="0"/>
+            <a:endParaRPr lang="ar-SA" sz="1650" dirty="0"/>
           </a:p>
         </p:txBody>
       </p:sp>
@@ -3859,8 +3859,8 @@
         </p:nvSpPr>
         <p:spPr>
           <a:xfrm>
-            <a:off x="457200" y="1661160"/>
-            <a:ext cx="5943600" cy="244475"/>
+            <a:off x="685800" y="2491740"/>
+            <a:ext cx="8915400" cy="366713"/>
           </a:xfrm>
           <a:prstGeom prst="rect">
             <a:avLst/>
@@ -3879,7 +3879,7 @@
               <a:buNone/>
             </a:pPr>
             <a:r>
-              <a:rPr lang="ar-SA" altLang="en-US" sz="1100" dirty="0">
+              <a:rPr lang="ar-SA" altLang="en-US" sz="1650" dirty="0">
                 <a:solidFill>
                   <a:srgbClr val="101820"/>
                 </a:solidFill>
@@ -3889,7 +3889,7 @@
               </a:rPr>
               <a:t>☐  الحد الأدنى: الرأسي 120 بكسل عرضاً، الأفقي 200، الرمز وحده 40.</a:t>
             </a:r>
-            <a:endParaRPr lang="ar-SA" sz="1100" dirty="0"/>
+            <a:endParaRPr lang="ar-SA" sz="1650" dirty="0"/>
           </a:p>
         </p:txBody>
       </p:sp>
@@ -3901,8 +3901,8 @@
         </p:nvSpPr>
         <p:spPr>
           <a:xfrm>
-            <a:off x="457200" y="1926590"/>
-            <a:ext cx="5943600" cy="244475"/>
+            <a:off x="685800" y="2889885"/>
+            <a:ext cx="8915400" cy="366713"/>
           </a:xfrm>
           <a:prstGeom prst="rect">
             <a:avLst/>
@@ -3921,7 +3921,7 @@
               <a:buNone/>
             </a:pPr>
             <a:r>
-              <a:rPr lang="ar-SA" altLang="en-US" sz="1100" dirty="0">
+              <a:rPr lang="ar-SA" altLang="en-US" sz="1650" dirty="0">
                 <a:solidFill>
                   <a:srgbClr val="101820"/>
                 </a:solidFill>
@@ -3931,7 +3931,7 @@
               </a:rPr>
               <a:t>☐  النقشة: بلوكات كاملة فقط (لا قصّ)، أقلها 2×2، لا تلامس الحافة.</a:t>
             </a:r>
-            <a:endParaRPr lang="ar-SA" sz="1100" dirty="0"/>
+            <a:endParaRPr lang="ar-SA" sz="1650" dirty="0"/>
           </a:p>
         </p:txBody>
       </p:sp>
@@ -3943,8 +3943,8 @@
         </p:nvSpPr>
         <p:spPr>
           <a:xfrm>
-            <a:off x="457200" y="2192020"/>
-            <a:ext cx="5943600" cy="244475"/>
+            <a:off x="685800" y="3288030"/>
+            <a:ext cx="8915400" cy="366713"/>
           </a:xfrm>
           <a:prstGeom prst="rect">
             <a:avLst/>
@@ -3963,7 +3963,7 @@
               <a:buNone/>
             </a:pPr>
             <a:r>
-              <a:rPr lang="ar-SA" altLang="en-US" sz="1100" dirty="0">
+              <a:rPr lang="ar-SA" altLang="en-US" sz="1650" dirty="0">
                 <a:solidFill>
                   <a:srgbClr val="101820"/>
                 </a:solidFill>
@@ -3973,7 +3973,7 @@
               </a:rPr>
               <a:t>☐  الخط العربي Almarai فقط؛ اللاتيني كما في القالب. لا خط ثالث.</a:t>
             </a:r>
-            <a:endParaRPr lang="ar-SA" sz="1100" dirty="0"/>
+            <a:endParaRPr lang="ar-SA" sz="1650" dirty="0"/>
           </a:p>
         </p:txBody>
       </p:sp>
@@ -3985,8 +3985,8 @@
         </p:nvSpPr>
         <p:spPr>
           <a:xfrm>
-            <a:off x="457200" y="2457450"/>
-            <a:ext cx="5943600" cy="244475"/>
+            <a:off x="685800" y="3686175"/>
+            <a:ext cx="8915400" cy="366713"/>
           </a:xfrm>
           <a:prstGeom prst="rect">
             <a:avLst/>
@@ -4005,7 +4005,7 @@
               <a:buNone/>
             </a:pPr>
             <a:r>
-              <a:rPr lang="ar-SA" altLang="en-US" sz="1100" dirty="0">
+              <a:rPr lang="ar-SA" altLang="en-US" sz="1650" dirty="0">
                 <a:solidFill>
                   <a:srgbClr val="101820"/>
                 </a:solidFill>
@@ -4015,7 +4015,7 @@
               </a:rPr>
               <a:t>☐  الألوان من Brand Kit فقط؛ لا أصفر/رمادي/أخضر/بيج كنص على أبيض.</a:t>
             </a:r>
-            <a:endParaRPr lang="ar-SA" sz="1100" dirty="0"/>
+            <a:endParaRPr lang="ar-SA" sz="1650" dirty="0"/>
           </a:p>
         </p:txBody>
       </p:sp>
@@ -4027,8 +4027,8 @@
         </p:nvSpPr>
         <p:spPr>
           <a:xfrm>
-            <a:off x="457200" y="2722880"/>
-            <a:ext cx="5943600" cy="244475"/>
+            <a:off x="685800" y="4084320"/>
+            <a:ext cx="8915400" cy="366713"/>
           </a:xfrm>
           <a:prstGeom prst="rect">
             <a:avLst/>
@@ -4047,7 +4047,7 @@
               <a:buNone/>
             </a:pPr>
             <a:r>
-              <a:rPr lang="ar-SA" altLang="en-US" sz="1100" dirty="0">
+              <a:rPr lang="ar-SA" altLang="en-US" sz="1650" dirty="0">
                 <a:solidFill>
                   <a:srgbClr val="101820"/>
                 </a:solidFill>
@@ -4057,7 +4057,7 @@
               </a:rPr>
               <a:t>☐  لا آيات، لا أسماء الله، لا صور للكعبة أو الحرم كزخرفة.</a:t>
             </a:r>
-            <a:endParaRPr lang="ar-SA" sz="1100" dirty="0"/>
+            <a:endParaRPr lang="ar-SA" sz="1650" dirty="0"/>
           </a:p>
         </p:txBody>
       </p:sp>
@@ -4069,8 +4069,8 @@
         </p:nvSpPr>
         <p:spPr>
           <a:xfrm>
-            <a:off x="457200" y="2988310"/>
-            <a:ext cx="5943600" cy="244475"/>
+            <a:off x="685800" y="4482465"/>
+            <a:ext cx="8915400" cy="366713"/>
           </a:xfrm>
           <a:prstGeom prst="rect">
             <a:avLst/>
@@ -4089,7 +4089,7 @@
               <a:buNone/>
             </a:pPr>
             <a:r>
-              <a:rPr lang="ar-SA" altLang="en-US" sz="1100" dirty="0">
+              <a:rPr lang="ar-SA" altLang="en-US" sz="1650" dirty="0">
                 <a:solidFill>
                   <a:srgbClr val="101820"/>
                 </a:solidFill>
@@ -4099,7 +4099,7 @@
               </a:rPr>
               <a:t>☐  النص العربي RTL، الأرقام والهواتف LTR داخل السطر.</a:t>
             </a:r>
-            <a:endParaRPr lang="ar-SA" sz="1100" dirty="0"/>
+            <a:endParaRPr lang="ar-SA" sz="1650" dirty="0"/>
           </a:p>
         </p:txBody>
       </p:sp>
@@ -4111,8 +4111,8 @@
         </p:nvSpPr>
         <p:spPr>
           <a:xfrm>
-            <a:off x="457200" y="3253740"/>
-            <a:ext cx="5943600" cy="244475"/>
+            <a:off x="685800" y="4880610"/>
+            <a:ext cx="8915400" cy="366713"/>
           </a:xfrm>
           <a:prstGeom prst="rect">
             <a:avLst/>
@@ -4131,7 +4131,7 @@
               <a:buNone/>
             </a:pPr>
             <a:r>
-              <a:rPr lang="ar-SA" altLang="en-US" sz="1100" dirty="0">
+              <a:rPr lang="ar-SA" altLang="en-US" sz="1650" dirty="0">
                 <a:solidFill>
                   <a:srgbClr val="101820"/>
                 </a:solidFill>
@@ -4141,7 +4141,7 @@
               </a:rPr>
               <a:t>☐  أي نص فوق صورة يحتاج تدرجاً أسود تحته (موجود في صفحة العقار).</a:t>
             </a:r>
-            <a:endParaRPr lang="ar-SA" sz="1100" dirty="0"/>
+            <a:endParaRPr lang="ar-SA" sz="1650" dirty="0"/>
           </a:p>
         </p:txBody>
       </p:sp>
@@ -4153,8 +4153,8 @@
         </p:nvSpPr>
         <p:spPr>
           <a:xfrm>
-            <a:off x="457200" y="3519170"/>
-            <a:ext cx="5943600" cy="244475"/>
+            <a:off x="685800" y="5278755"/>
+            <a:ext cx="8915400" cy="366713"/>
           </a:xfrm>
           <a:prstGeom prst="rect">
             <a:avLst/>
@@ -4173,7 +4173,7 @@
               <a:buNone/>
             </a:pPr>
             <a:r>
-              <a:rPr lang="ar-SA" altLang="en-US" sz="1100" dirty="0">
+              <a:rPr lang="ar-SA" altLang="en-US" sz="1650" dirty="0">
                 <a:solidFill>
                   <a:srgbClr val="101820"/>
                 </a:solidFill>
@@ -4183,7 +4183,7 @@
               </a:rPr>
               <a:t>☐  احذف هذه الصفحة قبل التصدير. التصدير: PNG للسوشيال.</a:t>
             </a:r>
-            <a:endParaRPr lang="ar-SA" sz="1100" dirty="0"/>
+            <a:endParaRPr lang="ar-SA" sz="1650" dirty="0"/>
           </a:p>
         </p:txBody>
       </p:sp>

</xml_diff>